<commit_message>
Polish investor pitch impact and closing slides
</commit_message>
<xml_diff>
--- a/docs/investors presentation/KungFlow Investor Pitch.pptx
+++ b/docs/investors presentation/KungFlow Investor Pitch.pptx
@@ -5,7 +5,7 @@
     <p:sldMasterId id="2147483648" r:id="rId1"/>
   </p:sldMasterIdLst>
   <p:notesMasterIdLst>
-    <p:notesMasterId r:id="rId14"/>
+    <p:notesMasterId r:id="rId15"/>
   </p:notesMasterIdLst>
   <p:sldIdLst>
     <p:sldId id="256" r:id="rId2"/>
@@ -20,13 +20,14 @@
     <p:sldId id="264" r:id="rId11"/>
     <p:sldId id="265" r:id="rId12"/>
     <p:sldId id="266" r:id="rId13"/>
+    <p:sldId id="268" r:id="rId14"/>
   </p:sldIdLst>
   <p:sldSz cx="9144000" cy="5143500" type="screen16x9"/>
   <p:notesSz cx="5143500" cy="9144000"/>
   <p:embeddedFontLst>
     <p:embeddedFont>
       <p:font typeface="Inter" panose="020B0604020202020204" charset="0"/>
-      <p:regular r:id="rId15"/>
+      <p:regular r:id="rId16"/>
     </p:embeddedFont>
   </p:embeddedFontLst>
   <p:defaultTextStyle>
@@ -572,6 +573,90 @@
             <a:fld id="{F7021451-1387-4CA6-816F-3879F97B5CBC}" type="slidenum">
               <a:rPr lang="en-US"/>
               <a:t>12</a:t>
+            </a:fld>
+            <a:endParaRPr lang="en-US"/>
+          </a:p>
+        </p:txBody>
+      </p:sp>
+    </p:spTree>
+    <p:extLst>
+      <p:ext uri="{BB962C8B-B14F-4D97-AF65-F5344CB8AC3E}">
+        <p14:creationId xmlns:p14="http://schemas.microsoft.com/office/powerpoint/2010/main" val="1024086991"/>
+      </p:ext>
+    </p:extLst>
+  </p:cSld>
+  <p:clrMapOvr>
+    <a:masterClrMapping/>
+  </p:clrMapOvr>
+</p:notes>
+</file>
+
+<file path=ppt/notesSlides/notesSlide13.xml><?xml version="1.0" encoding="utf-8"?>
+<p:notes xmlns:a="http://schemas.openxmlformats.org/drawingml/2006/main" xmlns:r="http://schemas.openxmlformats.org/officeDocument/2006/relationships" xmlns:p="http://schemas.openxmlformats.org/presentationml/2006/main">
+  <p:cSld>
+    <p:spTree>
+      <p:nvGrpSpPr>
+        <p:cNvPr id="1" name=""/>
+        <p:cNvGrpSpPr/>
+        <p:nvPr/>
+      </p:nvGrpSpPr>
+      <p:grpSpPr>
+        <a:xfrm>
+          <a:off x="0" y="0"/>
+          <a:ext cx="0" cy="0"/>
+          <a:chOff x="0" y="0"/>
+          <a:chExt cx="0" cy="0"/>
+        </a:xfrm>
+      </p:grpSpPr>
+      <p:sp>
+        <p:nvSpPr>
+          <p:cNvPr id="2" name="Slide Image Placeholder 1"/>
+          <p:cNvSpPr>
+            <a:spLocks noGrp="1" noRot="1" noChangeAspect="1"/>
+          </p:cNvSpPr>
+          <p:nvPr>
+            <p:ph type="sldImg"/>
+          </p:nvPr>
+        </p:nvSpPr>
+        <p:spPr/>
+      </p:sp>
+      <p:sp>
+        <p:nvSpPr>
+          <p:cNvPr id="3" name="Notes Placeholder 2"/>
+          <p:cNvSpPr>
+            <a:spLocks noGrp="1"/>
+          </p:cNvSpPr>
+          <p:nvPr>
+            <p:ph type="body" idx="1"/>
+          </p:nvPr>
+        </p:nvSpPr>
+        <p:spPr/>
+        <p:txBody>
+          <a:bodyPr/>
+          <a:lstStyle/>
+          <a:p>
+            <a:endParaRPr lang="en-US" dirty="0"/>
+          </a:p>
+        </p:txBody>
+      </p:sp>
+      <p:sp>
+        <p:nvSpPr>
+          <p:cNvPr id="4" name="Slide Number Placeholder 3"/>
+          <p:cNvSpPr>
+            <a:spLocks noGrp="1"/>
+          </p:cNvSpPr>
+          <p:nvPr>
+            <p:ph type="sldNum" sz="quarter" idx="10"/>
+          </p:nvPr>
+        </p:nvSpPr>
+        <p:spPr/>
+        <p:txBody>
+          <a:bodyPr/>
+          <a:lstStyle/>
+          <a:p>
+            <a:fld id="{F7021451-1387-4CA6-816F-3879F97B5CBC}" type="slidenum">
+              <a:rPr lang="en-US"/>
+              <a:t>13</a:t>
             </a:fld>
             <a:endParaRPr lang="en-US"/>
           </a:p>
@@ -8599,6 +8684,233 @@
 </p:sld>
 </file>
 
+<file path=ppt/slides/slide13.xml><?xml version="1.0" encoding="utf-8"?>
+<p:sld xmlns:a="http://schemas.openxmlformats.org/drawingml/2006/main" xmlns:r="http://schemas.openxmlformats.org/officeDocument/2006/relationships" xmlns:p="http://schemas.openxmlformats.org/presentationml/2006/main">
+  <p:cSld name="Slide 7">
+    <p:bg>
+      <p:bgPr>
+        <a:solidFill>
+          <a:srgbClr val="0D1117"/>
+        </a:solidFill>
+        <a:effectLst/>
+      </p:bgPr>
+    </p:bg>
+    <p:spTree>
+      <p:nvGrpSpPr>
+        <p:cNvPr id="1" name=""/>
+        <p:cNvGrpSpPr/>
+        <p:nvPr/>
+      </p:nvGrpSpPr>
+      <p:grpSpPr>
+        <a:xfrm>
+          <a:off x="0" y="0"/>
+          <a:ext cx="0" cy="0"/>
+          <a:chOff x="0" y="0"/>
+          <a:chExt cx="0" cy="0"/>
+        </a:xfrm>
+      </p:grpSpPr>
+      <p:sp>
+        <p:nvSpPr>
+          <p:cNvPr id="2" name="Text 0"/>
+          <p:cNvSpPr/>
+          <p:nvPr/>
+        </p:nvSpPr>
+        <p:spPr>
+          <a:xfrm>
+            <a:off x="71021" y="2116215"/>
+            <a:ext cx="9037468" cy="263001"/>
+          </a:xfrm>
+          <a:prstGeom prst="rect">
+            <a:avLst/>
+          </a:prstGeom>
+          <a:noFill/>
+          <a:ln/>
+        </p:spPr>
+        <p:txBody>
+          <a:bodyPr wrap="square" lIns="0" tIns="0" rIns="0" bIns="0" rtlCol="0" anchor="t"/>
+          <a:lstStyle/>
+          <a:p>
+            <a:pPr algn="ctr">
+              <a:lnSpc>
+                <a:spcPts val="1638"/>
+              </a:lnSpc>
+            </a:pPr>
+            <a:endParaRPr lang="en-US" sz="1354" dirty="0"/>
+          </a:p>
+        </p:txBody>
+      </p:sp>
+      <p:sp>
+        <p:nvSpPr>
+          <p:cNvPr id="3" name="תיבת טקסט 2">
+            <a:extLst>
+              <a:ext uri="{FF2B5EF4-FFF2-40B4-BE49-F238E27FC236}">
+                <a16:creationId xmlns:a16="http://schemas.microsoft.com/office/drawing/2014/main" id="{C3B2EE5E-6AE8-F34D-0AA3-03888F81D478}"/>
+              </a:ext>
+            </a:extLst>
+          </p:cNvPr>
+          <p:cNvSpPr txBox="1"/>
+          <p:nvPr/>
+        </p:nvSpPr>
+        <p:spPr>
+          <a:xfrm>
+            <a:off x="2286000" y="1714500"/>
+            <a:ext cx="4572000" cy="635000"/>
+          </a:xfrm>
+          <a:prstGeom prst="rect">
+            <a:avLst/>
+          </a:prstGeom>
+          <a:noFill/>
+        </p:spPr>
+        <p:txBody>
+          <a:bodyPr vert="horz" wrap="square" lIns="0" tIns="0" rIns="0" bIns="0" rtlCol="0">
+            <a:noAutofit/>
+          </a:bodyPr>
+          <a:lstStyle/>
+          <a:p>
+            <a:pPr algn="ctr"/>
+            <a:r>
+              <a:rPr lang="en-US" sz="3200" b="1">
+                <a:solidFill>
+                  <a:srgbClr val="FFFFFF"/>
+                </a:solidFill>
+                <a:latin typeface="Aptos" panose="020B0004020202020204" pitchFamily="34" charset="0"/>
+              </a:rPr>
+              <a:t>THANK YOU</a:t>
+            </a:r>
+            <a:endParaRPr lang="en-US" sz="3200" b="1" dirty="0">
+              <a:solidFill>
+                <a:srgbClr val="FFFFFF"/>
+              </a:solidFill>
+              <a:latin typeface="Aptos" panose="020B0004020202020204" pitchFamily="34" charset="0"/>
+            </a:endParaRPr>
+          </a:p>
+        </p:txBody>
+      </p:sp>
+      <p:pic>
+        <p:nvPicPr>
+          <p:cNvPr id="7" name="KungFlow Logo Small 3">
+            <a:extLst>
+              <a:ext uri="{FF2B5EF4-FFF2-40B4-BE49-F238E27FC236}">
+                <a16:creationId xmlns:a16="http://schemas.microsoft.com/office/drawing/2014/main" id="{C0E8A816-11BD-7AE2-B4BF-530F55E6AD34}"/>
+              </a:ext>
+            </a:extLst>
+          </p:cNvPr>
+          <p:cNvPicPr>
+            <a:picLocks/>
+          </p:cNvPicPr>
+          <p:nvPr/>
+        </p:nvPicPr>
+        <p:blipFill>
+          <a:blip r:embed="rId3"/>
+          <a:stretch>
+            <a:fillRect/>
+          </a:stretch>
+        </p:blipFill>
+        <p:spPr>
+          <a:xfrm>
+            <a:off x="8648700" y="190500"/>
+            <a:ext cx="292100" cy="292100"/>
+          </a:xfrm>
+          <a:prstGeom prst="rect">
+            <a:avLst/>
+          </a:prstGeom>
+        </p:spPr>
+      </p:pic>
+      <p:sp>
+        <p:nvSpPr>
+          <p:cNvPr id="4" name="תיבת טקסט 3">
+            <a:extLst>
+              <a:ext uri="{FF2B5EF4-FFF2-40B4-BE49-F238E27FC236}">
+                <a16:creationId xmlns:a16="http://schemas.microsoft.com/office/drawing/2014/main" id="{8C5718E6-3A93-23A0-5428-55798A85335D}"/>
+              </a:ext>
+            </a:extLst>
+          </p:cNvPr>
+          <p:cNvSpPr txBox="1"/>
+          <p:nvPr/>
+        </p:nvSpPr>
+        <p:spPr>
+          <a:xfrm>
+            <a:off x="2286000" y="2603500"/>
+            <a:ext cx="4572000" cy="369332"/>
+          </a:xfrm>
+          <a:prstGeom prst="rect">
+            <a:avLst/>
+          </a:prstGeom>
+          <a:noFill/>
+        </p:spPr>
+        <p:txBody>
+          <a:bodyPr vert="horz" rtlCol="0">
+            <a:spAutoFit/>
+          </a:bodyPr>
+          <a:lstStyle/>
+          <a:p>
+            <a:pPr algn="ctr"/>
+            <a:r>
+              <a:rPr lang="en-US">
+                <a:solidFill>
+                  <a:srgbClr val="D2DAE8"/>
+                </a:solidFill>
+                <a:latin typeface="Aptos" panose="020B0004020202020204" pitchFamily="34" charset="0"/>
+              </a:rPr>
+              <a:t>Questions?</a:t>
+            </a:r>
+          </a:p>
+        </p:txBody>
+      </p:sp>
+      <p:sp>
+        <p:nvSpPr>
+          <p:cNvPr id="5" name="תיבת טקסט 4">
+            <a:extLst>
+              <a:ext uri="{FF2B5EF4-FFF2-40B4-BE49-F238E27FC236}">
+                <a16:creationId xmlns:a16="http://schemas.microsoft.com/office/drawing/2014/main" id="{C2DB47A3-B05A-2EA1-7762-4965CADF7AB3}"/>
+              </a:ext>
+            </a:extLst>
+          </p:cNvPr>
+          <p:cNvSpPr txBox="1"/>
+          <p:nvPr/>
+        </p:nvSpPr>
+        <p:spPr>
+          <a:xfrm>
+            <a:off x="2032000" y="3200400"/>
+            <a:ext cx="5080000" cy="230832"/>
+          </a:xfrm>
+          <a:prstGeom prst="rect">
+            <a:avLst/>
+          </a:prstGeom>
+          <a:noFill/>
+        </p:spPr>
+        <p:txBody>
+          <a:bodyPr vert="horz" rtlCol="0">
+            <a:spAutoFit/>
+          </a:bodyPr>
+          <a:lstStyle/>
+          <a:p>
+            <a:pPr algn="ctr"/>
+            <a:r>
+              <a:rPr lang="en-US" sz="900">
+                <a:solidFill>
+                  <a:srgbClr val="8091AE"/>
+                </a:solidFill>
+                <a:latin typeface="Aptos" panose="020B0004020202020204" pitchFamily="34" charset="0"/>
+              </a:rPr>
+              <a:t>KungFlow  |  Reclaim Your Focus. Measure Your Mind.</a:t>
+            </a:r>
+          </a:p>
+        </p:txBody>
+      </p:sp>
+    </p:spTree>
+    <p:extLst>
+      <p:ext uri="{BB962C8B-B14F-4D97-AF65-F5344CB8AC3E}">
+        <p14:creationId xmlns:p14="http://schemas.microsoft.com/office/powerpoint/2010/main" val="983761898"/>
+      </p:ext>
+    </p:extLst>
+  </p:cSld>
+  <p:clrMapOvr>
+    <a:masterClrMapping/>
+  </p:clrMapOvr>
+</p:sld>
+</file>
+
 <file path=ppt/slides/slide2.xml><?xml version="1.0" encoding="utf-8"?>
 <p:sld xmlns:a="http://schemas.openxmlformats.org/drawingml/2006/main" xmlns:r="http://schemas.openxmlformats.org/officeDocument/2006/relationships" xmlns:p="http://schemas.openxmlformats.org/presentationml/2006/main">
   <p:cSld name="Slide 2">
@@ -14562,7 +14874,7 @@
               <a:buNone/>
             </a:pPr>
             <a:r>
-              <a:rPr lang="en-US" sz="855" dirty="0">
+              <a:rPr lang="en-US" sz="1000" dirty="0">
                 <a:solidFill>
                   <a:srgbClr val="D6DEF0">
                     <a:alpha val="99000"/>
@@ -14574,20 +14886,223 @@
               </a:rPr>
               <a:t>KungFlow contributes to two UN Sustainable Development Goals</a:t>
             </a:r>
-            <a:endParaRPr lang="en-US" sz="855" dirty="0"/>
-          </a:p>
-        </p:txBody>
-      </p:sp>
-      <p:sp>
-        <p:nvSpPr>
-          <p:cNvPr id="6" name="Shape 4"/>
-          <p:cNvSpPr/>
-          <p:nvPr/>
-        </p:nvSpPr>
-        <p:spPr>
-          <a:xfrm>
-            <a:off x="571500" y="1247775"/>
-            <a:ext cx="285750" cy="285750"/>
+            <a:endParaRPr lang="en-US" sz="1000" dirty="0"/>
+          </a:p>
+        </p:txBody>
+      </p:sp>
+      <p:sp>
+        <p:nvSpPr>
+          <p:cNvPr id="8" name="Text 6"/>
+          <p:cNvSpPr/>
+          <p:nvPr/>
+        </p:nvSpPr>
+        <p:spPr>
+          <a:xfrm>
+            <a:off x="1155700" y="1193799"/>
+            <a:ext cx="1143000" cy="114300"/>
+          </a:xfrm>
+          <a:prstGeom prst="rect">
+            <a:avLst/>
+          </a:prstGeom>
+          <a:noFill/>
+          <a:ln/>
+        </p:spPr>
+        <p:txBody>
+          <a:bodyPr wrap="square" lIns="0" tIns="0" rIns="0" bIns="0" rtlCol="0" anchor="t"/>
+          <a:lstStyle/>
+          <a:p>
+            <a:pPr marL="0" indent="0" algn="l">
+              <a:lnSpc>
+                <a:spcPts val="604"/>
+              </a:lnSpc>
+              <a:buNone/>
+            </a:pPr>
+            <a:r>
+              <a:rPr lang="en-US" sz="650" b="1" dirty="0">
+                <a:solidFill>
+                  <a:srgbClr val="2A9E3B">
+                    <a:alpha val="99000"/>
+                  </a:srgbClr>
+                </a:solidFill>
+                <a:latin typeface="Inter" pitchFamily="34" charset="0"/>
+                <a:ea typeface="Inter" pitchFamily="34" charset="-122"/>
+                <a:cs typeface="Inter" pitchFamily="34" charset="-120"/>
+              </a:rPr>
+              <a:t>SDG 3</a:t>
+            </a:r>
+            <a:endParaRPr lang="en-US" sz="650" dirty="0"/>
+          </a:p>
+        </p:txBody>
+      </p:sp>
+      <p:sp>
+        <p:nvSpPr>
+          <p:cNvPr id="9" name="Text 7"/>
+          <p:cNvSpPr/>
+          <p:nvPr/>
+        </p:nvSpPr>
+        <p:spPr>
+          <a:xfrm>
+            <a:off x="1155700" y="1346199"/>
+            <a:ext cx="2794000" cy="152400"/>
+          </a:xfrm>
+          <a:prstGeom prst="rect">
+            <a:avLst/>
+          </a:prstGeom>
+          <a:noFill/>
+          <a:ln/>
+        </p:spPr>
+        <p:txBody>
+          <a:bodyPr wrap="square" lIns="0" tIns="0" rIns="0" bIns="0" rtlCol="0" anchor="t"/>
+          <a:lstStyle/>
+          <a:p>
+            <a:pPr marL="0" indent="0" algn="l">
+              <a:lnSpc>
+                <a:spcPts val="776"/>
+              </a:lnSpc>
+              <a:buNone/>
+            </a:pPr>
+            <a:r>
+              <a:rPr lang="en-US" sz="800" b="1" dirty="0">
+                <a:solidFill>
+                  <a:srgbClr val="FFFFFF">
+                    <a:alpha val="99000"/>
+                  </a:srgbClr>
+                </a:solidFill>
+                <a:latin typeface="Inter" pitchFamily="34" charset="0"/>
+                <a:ea typeface="Inter" pitchFamily="34" charset="-122"/>
+                <a:cs typeface="Inter" pitchFamily="34" charset="-120"/>
+              </a:rPr>
+              <a:t>Good Health and Well-Being</a:t>
+            </a:r>
+            <a:endParaRPr lang="en-US" sz="800" dirty="0"/>
+          </a:p>
+        </p:txBody>
+      </p:sp>
+      <p:sp>
+        <p:nvSpPr>
+          <p:cNvPr id="12" name="Text 10"/>
+          <p:cNvSpPr/>
+          <p:nvPr/>
+        </p:nvSpPr>
+        <p:spPr>
+          <a:xfrm>
+            <a:off x="5251450" y="1193799"/>
+            <a:ext cx="1143000" cy="114300"/>
+          </a:xfrm>
+          <a:prstGeom prst="rect">
+            <a:avLst/>
+          </a:prstGeom>
+          <a:noFill/>
+          <a:ln/>
+        </p:spPr>
+        <p:txBody>
+          <a:bodyPr wrap="square" lIns="0" tIns="0" rIns="0" bIns="0" rtlCol="0" anchor="t"/>
+          <a:lstStyle/>
+          <a:p>
+            <a:pPr marL="0" indent="0" algn="l">
+              <a:lnSpc>
+                <a:spcPts val="604"/>
+              </a:lnSpc>
+              <a:buNone/>
+            </a:pPr>
+            <a:r>
+              <a:rPr lang="en-US" sz="650" b="1" dirty="0">
+                <a:solidFill>
+                  <a:srgbClr val="A21942">
+                    <a:alpha val="99000"/>
+                  </a:srgbClr>
+                </a:solidFill>
+                <a:latin typeface="Inter" pitchFamily="34" charset="0"/>
+                <a:ea typeface="Inter" pitchFamily="34" charset="-122"/>
+                <a:cs typeface="Inter" pitchFamily="34" charset="-120"/>
+              </a:rPr>
+              <a:t>SDG 8</a:t>
+            </a:r>
+            <a:endParaRPr lang="en-US" sz="650" dirty="0"/>
+          </a:p>
+        </p:txBody>
+      </p:sp>
+      <p:sp>
+        <p:nvSpPr>
+          <p:cNvPr id="13" name="Text 11"/>
+          <p:cNvSpPr/>
+          <p:nvPr/>
+        </p:nvSpPr>
+        <p:spPr>
+          <a:xfrm>
+            <a:off x="5251450" y="1346199"/>
+            <a:ext cx="2984500" cy="152400"/>
+          </a:xfrm>
+          <a:prstGeom prst="rect">
+            <a:avLst/>
+          </a:prstGeom>
+          <a:noFill/>
+          <a:ln/>
+        </p:spPr>
+        <p:txBody>
+          <a:bodyPr wrap="square" lIns="0" tIns="0" rIns="0" bIns="0" rtlCol="0" anchor="t"/>
+          <a:lstStyle/>
+          <a:p>
+            <a:pPr marL="0" indent="0" algn="l">
+              <a:lnSpc>
+                <a:spcPts val="776"/>
+              </a:lnSpc>
+              <a:buNone/>
+            </a:pPr>
+            <a:r>
+              <a:rPr lang="en-US" sz="800" b="1" dirty="0">
+                <a:solidFill>
+                  <a:srgbClr val="FFFFFF">
+                    <a:alpha val="99000"/>
+                  </a:srgbClr>
+                </a:solidFill>
+                <a:latin typeface="Inter" pitchFamily="34" charset="0"/>
+                <a:ea typeface="Inter" pitchFamily="34" charset="-122"/>
+                <a:cs typeface="Inter" pitchFamily="34" charset="-120"/>
+              </a:rPr>
+              <a:t>Decent Work and Economic Growth</a:t>
+            </a:r>
+            <a:endParaRPr lang="en-US" sz="800" dirty="0"/>
+          </a:p>
+        </p:txBody>
+      </p:sp>
+      <p:sp>
+        <p:nvSpPr>
+          <p:cNvPr id="14" name="Shape 12"/>
+          <p:cNvSpPr/>
+          <p:nvPr/>
+        </p:nvSpPr>
+        <p:spPr>
+          <a:xfrm>
+            <a:off x="571500" y="1628775"/>
+            <a:ext cx="3905250" cy="2286000"/>
+          </a:xfrm>
+          <a:prstGeom prst="rect">
+            <a:avLst/>
+          </a:prstGeom>
+          <a:solidFill>
+            <a:srgbClr val="1F2430"/>
+          </a:solidFill>
+          <a:ln/>
+        </p:spPr>
+        <p:txBody>
+          <a:bodyPr/>
+          <a:lstStyle/>
+          <a:p>
+            <a:endParaRPr lang="en-US"/>
+          </a:p>
+        </p:txBody>
+      </p:sp>
+      <p:sp>
+        <p:nvSpPr>
+          <p:cNvPr id="15" name="Shape 13"/>
+          <p:cNvSpPr/>
+          <p:nvPr/>
+        </p:nvSpPr>
+        <p:spPr>
+          <a:xfrm>
+            <a:off x="571500" y="1628775"/>
+            <a:ext cx="3905250" cy="28575"/>
           </a:xfrm>
           <a:prstGeom prst="rect">
             <a:avLst/>
@@ -14607,33 +15122,60 @@
       </p:sp>
       <p:sp>
         <p:nvSpPr>
-          <p:cNvPr id="7" name="Text 5"/>
-          <p:cNvSpPr/>
-          <p:nvPr/>
-        </p:nvSpPr>
-        <p:spPr>
-          <a:xfrm>
-            <a:off x="571500" y="1285875"/>
-            <a:ext cx="285750" cy="209550"/>
-          </a:xfrm>
-          <a:prstGeom prst="rect">
-            <a:avLst/>
-          </a:prstGeom>
-          <a:noFill/>
-          <a:ln/>
-        </p:spPr>
-        <p:txBody>
-          <a:bodyPr wrap="square" lIns="0" tIns="0" rIns="0" bIns="0" rtlCol="0" anchor="t"/>
-          <a:lstStyle/>
-          <a:p>
-            <a:pPr marL="0" indent="0" algn="ctr">
-              <a:lnSpc>
-                <a:spcPts val="1552"/>
-              </a:lnSpc>
-              <a:buNone/>
-            </a:pPr>
-            <a:r>
-              <a:rPr lang="en-US" sz="1283" b="1" dirty="0">
+          <p:cNvPr id="16" name="Shape 14"/>
+          <p:cNvSpPr/>
+          <p:nvPr/>
+        </p:nvSpPr>
+        <p:spPr>
+          <a:xfrm>
+            <a:off x="666750" y="1752600"/>
+            <a:ext cx="19050" cy="428625"/>
+          </a:xfrm>
+          <a:prstGeom prst="rect">
+            <a:avLst/>
+          </a:prstGeom>
+          <a:solidFill>
+            <a:srgbClr val="2A9E3B"/>
+          </a:solidFill>
+          <a:ln/>
+        </p:spPr>
+        <p:txBody>
+          <a:bodyPr/>
+          <a:lstStyle/>
+          <a:p>
+            <a:endParaRPr lang="en-US"/>
+          </a:p>
+        </p:txBody>
+      </p:sp>
+      <p:sp>
+        <p:nvSpPr>
+          <p:cNvPr id="17" name="Text 15"/>
+          <p:cNvSpPr/>
+          <p:nvPr/>
+        </p:nvSpPr>
+        <p:spPr>
+          <a:xfrm>
+            <a:off x="771525" y="1752599"/>
+            <a:ext cx="3524250" cy="139700"/>
+          </a:xfrm>
+          <a:prstGeom prst="rect">
+            <a:avLst/>
+          </a:prstGeom>
+          <a:noFill/>
+          <a:ln/>
+        </p:spPr>
+        <p:txBody>
+          <a:bodyPr wrap="square" lIns="0" tIns="0" rIns="0" bIns="0" rtlCol="0" anchor="t"/>
+          <a:lstStyle/>
+          <a:p>
+            <a:pPr marL="0" indent="0" algn="l">
+              <a:lnSpc>
+                <a:spcPts val="733"/>
+              </a:lnSpc>
+              <a:buNone/>
+            </a:pPr>
+            <a:r>
+              <a:rPr lang="en-US" sz="800" b="1" dirty="0">
                 <a:solidFill>
                   <a:srgbClr val="FFFFFF">
                     <a:alpha val="99000"/>
@@ -14643,22 +15185,22 @@
                 <a:ea typeface="Inter" pitchFamily="34" charset="-122"/>
                 <a:cs typeface="Inter" pitchFamily="34" charset="-120"/>
               </a:rPr>
-              <a:t>3</a:t>
-            </a:r>
-            <a:endParaRPr lang="en-US" sz="1283" dirty="0"/>
-          </a:p>
-        </p:txBody>
-      </p:sp>
-      <p:sp>
-        <p:nvSpPr>
-          <p:cNvPr id="8" name="Text 6"/>
-          <p:cNvSpPr/>
-          <p:nvPr/>
-        </p:nvSpPr>
-        <p:spPr>
-          <a:xfrm>
-            <a:off x="933450" y="1257300"/>
-            <a:ext cx="952500" cy="80963"/>
+              <a:t>Reduces workplace stress and burnout</a:t>
+            </a:r>
+            <a:endParaRPr lang="en-US" sz="800" dirty="0"/>
+          </a:p>
+        </p:txBody>
+      </p:sp>
+      <p:sp>
+        <p:nvSpPr>
+          <p:cNvPr id="18" name="Text 16"/>
+          <p:cNvSpPr/>
+          <p:nvPr/>
+        </p:nvSpPr>
+        <p:spPr>
+          <a:xfrm>
+            <a:off x="771525" y="1895475"/>
+            <a:ext cx="3524250" cy="342900"/>
           </a:xfrm>
           <a:prstGeom prst="rect">
             <a:avLst/>
@@ -14672,37 +15214,64 @@
           <a:p>
             <a:pPr marL="0" indent="0" algn="l">
               <a:lnSpc>
-                <a:spcPts val="604"/>
-              </a:lnSpc>
-              <a:buNone/>
-            </a:pPr>
-            <a:r>
-              <a:rPr lang="en-US" sz="499" b="1" dirty="0">
-                <a:solidFill>
-                  <a:srgbClr val="2A9E3B">
-                    <a:alpha val="99000"/>
-                  </a:srgbClr>
-                </a:solidFill>
-                <a:latin typeface="Inter" pitchFamily="34" charset="0"/>
-                <a:ea typeface="Inter" pitchFamily="34" charset="-122"/>
-                <a:cs typeface="Inter" pitchFamily="34" charset="-120"/>
-              </a:rPr>
-              <a:t>SDG 3</a:t>
-            </a:r>
-            <a:endParaRPr lang="en-US" sz="499" dirty="0"/>
-          </a:p>
-        </p:txBody>
-      </p:sp>
-      <p:sp>
-        <p:nvSpPr>
-          <p:cNvPr id="9" name="Text 7"/>
-          <p:cNvSpPr/>
-          <p:nvPr/>
-        </p:nvSpPr>
-        <p:spPr>
-          <a:xfrm>
-            <a:off x="933450" y="1362075"/>
-            <a:ext cx="1905000" cy="104775"/>
+                <a:spcPts val="647"/>
+              </a:lnSpc>
+              <a:buNone/>
+            </a:pPr>
+            <a:r>
+              <a:rPr lang="en-US" sz="640" dirty="0">
+                <a:solidFill>
+                  <a:srgbClr val="66708A">
+                    <a:alpha val="99000"/>
+                  </a:srgbClr>
+                </a:solidFill>
+                <a:latin typeface="Inter" pitchFamily="34" charset="0"/>
+                <a:ea typeface="Inter" pitchFamily="34" charset="-122"/>
+                <a:cs typeface="Inter" pitchFamily="34" charset="-120"/>
+              </a:rPr>
+              <a:t>Chronic cognitive overload from constant notifications is directly linked to stress, anxiety disorders, and burnout. KungFlow removes that pressure automatically.</a:t>
+            </a:r>
+            <a:endParaRPr lang="en-US" sz="640" dirty="0"/>
+          </a:p>
+        </p:txBody>
+      </p:sp>
+      <p:sp>
+        <p:nvSpPr>
+          <p:cNvPr id="19" name="Shape 17"/>
+          <p:cNvSpPr/>
+          <p:nvPr/>
+        </p:nvSpPr>
+        <p:spPr>
+          <a:xfrm>
+            <a:off x="666750" y="2400300"/>
+            <a:ext cx="19050" cy="428625"/>
+          </a:xfrm>
+          <a:prstGeom prst="rect">
+            <a:avLst/>
+          </a:prstGeom>
+          <a:solidFill>
+            <a:srgbClr val="2A9E3B"/>
+          </a:solidFill>
+          <a:ln/>
+        </p:spPr>
+        <p:txBody>
+          <a:bodyPr/>
+          <a:lstStyle/>
+          <a:p>
+            <a:endParaRPr lang="en-US"/>
+          </a:p>
+        </p:txBody>
+      </p:sp>
+      <p:sp>
+        <p:nvSpPr>
+          <p:cNvPr id="20" name="Text 18"/>
+          <p:cNvSpPr/>
+          <p:nvPr/>
+        </p:nvSpPr>
+        <p:spPr>
+          <a:xfrm>
+            <a:off x="771525" y="2400299"/>
+            <a:ext cx="3524250" cy="139700"/>
           </a:xfrm>
           <a:prstGeom prst="rect">
             <a:avLst/>
@@ -14716,12 +15285,12 @@
           <a:p>
             <a:pPr marL="0" indent="0" algn="l">
               <a:lnSpc>
-                <a:spcPts val="776"/>
-              </a:lnSpc>
-              <a:buNone/>
-            </a:pPr>
-            <a:r>
-              <a:rPr lang="en-US" sz="641" b="1" dirty="0">
+                <a:spcPts val="733"/>
+              </a:lnSpc>
+              <a:buNone/>
+            </a:pPr>
+            <a:r>
+              <a:rPr lang="en-US" sz="800" b="1" dirty="0">
                 <a:solidFill>
                   <a:srgbClr val="FFFFFF">
                     <a:alpha val="99000"/>
@@ -14731,22 +15300,208 @@
                 <a:ea typeface="Inter" pitchFamily="34" charset="-122"/>
                 <a:cs typeface="Inter" pitchFamily="34" charset="-120"/>
               </a:rPr>
-              <a:t>Good Health and Well-Being</a:t>
-            </a:r>
-            <a:endParaRPr lang="en-US" sz="641" dirty="0"/>
-          </a:p>
-        </p:txBody>
-      </p:sp>
-      <p:sp>
-        <p:nvSpPr>
-          <p:cNvPr id="10" name="Shape 8"/>
-          <p:cNvSpPr/>
-          <p:nvPr/>
-        </p:nvSpPr>
-        <p:spPr>
-          <a:xfrm>
-            <a:off x="4667250" y="1247775"/>
-            <a:ext cx="285750" cy="285750"/>
+              <a:t>Protects mental health at work</a:t>
+            </a:r>
+            <a:endParaRPr lang="en-US" sz="800" dirty="0"/>
+          </a:p>
+        </p:txBody>
+      </p:sp>
+      <p:sp>
+        <p:nvSpPr>
+          <p:cNvPr id="21" name="Text 19"/>
+          <p:cNvSpPr/>
+          <p:nvPr/>
+        </p:nvSpPr>
+        <p:spPr>
+          <a:xfrm>
+            <a:off x="771525" y="2543175"/>
+            <a:ext cx="3524250" cy="342900"/>
+          </a:xfrm>
+          <a:prstGeom prst="rect">
+            <a:avLst/>
+          </a:prstGeom>
+          <a:noFill/>
+          <a:ln/>
+        </p:spPr>
+        <p:txBody>
+          <a:bodyPr wrap="square" lIns="0" tIns="0" rIns="0" bIns="0" rtlCol="0" anchor="t"/>
+          <a:lstStyle/>
+          <a:p>
+            <a:pPr marL="0" indent="0" algn="l">
+              <a:lnSpc>
+                <a:spcPts val="647"/>
+              </a:lnSpc>
+              <a:buNone/>
+            </a:pPr>
+            <a:r>
+              <a:rPr lang="en-US" sz="640" dirty="0">
+                <a:solidFill>
+                  <a:srgbClr val="66708A">
+                    <a:alpha val="99000"/>
+                  </a:srgbClr>
+                </a:solidFill>
+                <a:latin typeface="Inter" pitchFamily="34" charset="0"/>
+                <a:ea typeface="Inter" pitchFamily="34" charset="-122"/>
+                <a:cs typeface="Inter" pitchFamily="34" charset="-120"/>
+              </a:rPr>
+              <a:t>By monitoring load and activating the firewall before overload sets in, KungFlow gives employees breathing room during their most cognitively demanding hours.</a:t>
+            </a:r>
+            <a:endParaRPr lang="en-US" sz="640" dirty="0"/>
+          </a:p>
+        </p:txBody>
+      </p:sp>
+      <p:sp>
+        <p:nvSpPr>
+          <p:cNvPr id="22" name="Shape 20"/>
+          <p:cNvSpPr/>
+          <p:nvPr/>
+        </p:nvSpPr>
+        <p:spPr>
+          <a:xfrm>
+            <a:off x="666750" y="3048000"/>
+            <a:ext cx="19050" cy="428625"/>
+          </a:xfrm>
+          <a:prstGeom prst="rect">
+            <a:avLst/>
+          </a:prstGeom>
+          <a:solidFill>
+            <a:srgbClr val="2A9E3B"/>
+          </a:solidFill>
+          <a:ln/>
+        </p:spPr>
+        <p:txBody>
+          <a:bodyPr/>
+          <a:lstStyle/>
+          <a:p>
+            <a:endParaRPr lang="en-US"/>
+          </a:p>
+        </p:txBody>
+      </p:sp>
+      <p:sp>
+        <p:nvSpPr>
+          <p:cNvPr id="23" name="Text 21"/>
+          <p:cNvSpPr/>
+          <p:nvPr/>
+        </p:nvSpPr>
+        <p:spPr>
+          <a:xfrm>
+            <a:off x="771525" y="3047999"/>
+            <a:ext cx="3524250" cy="139700"/>
+          </a:xfrm>
+          <a:prstGeom prst="rect">
+            <a:avLst/>
+          </a:prstGeom>
+          <a:noFill/>
+          <a:ln/>
+        </p:spPr>
+        <p:txBody>
+          <a:bodyPr wrap="square" lIns="0" tIns="0" rIns="0" bIns="0" rtlCol="0" anchor="t"/>
+          <a:lstStyle/>
+          <a:p>
+            <a:pPr marL="0" indent="0" algn="l">
+              <a:lnSpc>
+                <a:spcPts val="733"/>
+              </a:lnSpc>
+              <a:buNone/>
+            </a:pPr>
+            <a:r>
+              <a:rPr lang="en-US" sz="800" b="1" dirty="0">
+                <a:solidFill>
+                  <a:srgbClr val="FFFFFF">
+                    <a:alpha val="99000"/>
+                  </a:srgbClr>
+                </a:solidFill>
+                <a:latin typeface="Inter" pitchFamily="34" charset="0"/>
+                <a:ea typeface="Inter" pitchFamily="34" charset="-122"/>
+                <a:cs typeface="Inter" pitchFamily="34" charset="-120"/>
+              </a:rPr>
+              <a:t>SDG Target 3.4</a:t>
+            </a:r>
+            <a:endParaRPr lang="en-US" sz="800" dirty="0"/>
+          </a:p>
+        </p:txBody>
+      </p:sp>
+      <p:sp>
+        <p:nvSpPr>
+          <p:cNvPr id="24" name="Text 22"/>
+          <p:cNvSpPr/>
+          <p:nvPr/>
+        </p:nvSpPr>
+        <p:spPr>
+          <a:xfrm>
+            <a:off x="771525" y="3190875"/>
+            <a:ext cx="3524250" cy="342900"/>
+          </a:xfrm>
+          <a:prstGeom prst="rect">
+            <a:avLst/>
+          </a:prstGeom>
+          <a:noFill/>
+          <a:ln/>
+        </p:spPr>
+        <p:txBody>
+          <a:bodyPr wrap="square" lIns="0" tIns="0" rIns="0" bIns="0" rtlCol="0" anchor="t"/>
+          <a:lstStyle/>
+          <a:p>
+            <a:pPr marL="0" indent="0" algn="l">
+              <a:lnSpc>
+                <a:spcPts val="647"/>
+              </a:lnSpc>
+              <a:buNone/>
+            </a:pPr>
+            <a:r>
+              <a:rPr lang="en-US" sz="640" dirty="0">
+                <a:solidFill>
+                  <a:srgbClr val="66708A">
+                    <a:alpha val="99000"/>
+                  </a:srgbClr>
+                </a:solidFill>
+                <a:latin typeface="Inter" pitchFamily="34" charset="0"/>
+                <a:ea typeface="Inter" pitchFamily="34" charset="-122"/>
+                <a:cs typeface="Inter" pitchFamily="34" charset="-120"/>
+              </a:rPr>
+              <a:t>Promote mental health and well-being, and reduce premature mortality from non-communicable diseases including stress-related conditions.</a:t>
+            </a:r>
+            <a:endParaRPr lang="en-US" sz="640" dirty="0"/>
+          </a:p>
+        </p:txBody>
+      </p:sp>
+      <p:sp>
+        <p:nvSpPr>
+          <p:cNvPr id="25" name="Shape 23"/>
+          <p:cNvSpPr/>
+          <p:nvPr/>
+        </p:nvSpPr>
+        <p:spPr>
+          <a:xfrm>
+            <a:off x="4667250" y="1628775"/>
+            <a:ext cx="3905250" cy="2286000"/>
+          </a:xfrm>
+          <a:prstGeom prst="rect">
+            <a:avLst/>
+          </a:prstGeom>
+          <a:solidFill>
+            <a:srgbClr val="1F2430"/>
+          </a:solidFill>
+          <a:ln/>
+        </p:spPr>
+        <p:txBody>
+          <a:bodyPr/>
+          <a:lstStyle/>
+          <a:p>
+            <a:endParaRPr lang="en-US"/>
+          </a:p>
+        </p:txBody>
+      </p:sp>
+      <p:sp>
+        <p:nvSpPr>
+          <p:cNvPr id="26" name="Shape 24"/>
+          <p:cNvSpPr/>
+          <p:nvPr/>
+        </p:nvSpPr>
+        <p:spPr>
+          <a:xfrm>
+            <a:off x="4667250" y="1628775"/>
+            <a:ext cx="3905250" cy="28575"/>
           </a:xfrm>
           <a:prstGeom prst="rect">
             <a:avLst/>
@@ -14766,33 +15521,60 @@
       </p:sp>
       <p:sp>
         <p:nvSpPr>
-          <p:cNvPr id="11" name="Text 9"/>
-          <p:cNvSpPr/>
-          <p:nvPr/>
-        </p:nvSpPr>
-        <p:spPr>
-          <a:xfrm>
-            <a:off x="4667250" y="1285875"/>
-            <a:ext cx="285750" cy="209550"/>
-          </a:xfrm>
-          <a:prstGeom prst="rect">
-            <a:avLst/>
-          </a:prstGeom>
-          <a:noFill/>
-          <a:ln/>
-        </p:spPr>
-        <p:txBody>
-          <a:bodyPr wrap="square" lIns="0" tIns="0" rIns="0" bIns="0" rtlCol="0" anchor="t"/>
-          <a:lstStyle/>
-          <a:p>
-            <a:pPr marL="0" indent="0" algn="ctr">
-              <a:lnSpc>
-                <a:spcPts val="1552"/>
-              </a:lnSpc>
-              <a:buNone/>
-            </a:pPr>
-            <a:r>
-              <a:rPr lang="en-US" sz="1283" b="1" dirty="0">
+          <p:cNvPr id="27" name="Shape 25"/>
+          <p:cNvSpPr/>
+          <p:nvPr/>
+        </p:nvSpPr>
+        <p:spPr>
+          <a:xfrm>
+            <a:off x="4762500" y="1752600"/>
+            <a:ext cx="19050" cy="428625"/>
+          </a:xfrm>
+          <a:prstGeom prst="rect">
+            <a:avLst/>
+          </a:prstGeom>
+          <a:solidFill>
+            <a:srgbClr val="A21942"/>
+          </a:solidFill>
+          <a:ln/>
+        </p:spPr>
+        <p:txBody>
+          <a:bodyPr/>
+          <a:lstStyle/>
+          <a:p>
+            <a:endParaRPr lang="en-US"/>
+          </a:p>
+        </p:txBody>
+      </p:sp>
+      <p:sp>
+        <p:nvSpPr>
+          <p:cNvPr id="28" name="Text 26"/>
+          <p:cNvSpPr/>
+          <p:nvPr/>
+        </p:nvSpPr>
+        <p:spPr>
+          <a:xfrm>
+            <a:off x="4867275" y="1752599"/>
+            <a:ext cx="3524250" cy="139700"/>
+          </a:xfrm>
+          <a:prstGeom prst="rect">
+            <a:avLst/>
+          </a:prstGeom>
+          <a:noFill/>
+          <a:ln/>
+        </p:spPr>
+        <p:txBody>
+          <a:bodyPr wrap="square" lIns="0" tIns="0" rIns="0" bIns="0" rtlCol="0" anchor="t"/>
+          <a:lstStyle/>
+          <a:p>
+            <a:pPr marL="0" indent="0" algn="l">
+              <a:lnSpc>
+                <a:spcPts val="733"/>
+              </a:lnSpc>
+              <a:buNone/>
+            </a:pPr>
+            <a:r>
+              <a:rPr lang="en-US" sz="800" b="1" dirty="0">
                 <a:solidFill>
                   <a:srgbClr val="FFFFFF">
                     <a:alpha val="99000"/>
@@ -14802,22 +15584,22 @@
                 <a:ea typeface="Inter" pitchFamily="34" charset="-122"/>
                 <a:cs typeface="Inter" pitchFamily="34" charset="-120"/>
               </a:rPr>
-              <a:t>8</a:t>
-            </a:r>
-            <a:endParaRPr lang="en-US" sz="1283" dirty="0"/>
-          </a:p>
-        </p:txBody>
-      </p:sp>
-      <p:sp>
-        <p:nvSpPr>
-          <p:cNvPr id="12" name="Text 10"/>
-          <p:cNvSpPr/>
-          <p:nvPr/>
-        </p:nvSpPr>
-        <p:spPr>
-          <a:xfrm>
-            <a:off x="5029200" y="1257300"/>
-            <a:ext cx="952500" cy="80963"/>
+              <a:t>$650B in productivity lost annually</a:t>
+            </a:r>
+            <a:endParaRPr lang="en-US" sz="800" dirty="0"/>
+          </a:p>
+        </p:txBody>
+      </p:sp>
+      <p:sp>
+        <p:nvSpPr>
+          <p:cNvPr id="29" name="Text 27"/>
+          <p:cNvSpPr/>
+          <p:nvPr/>
+        </p:nvSpPr>
+        <p:spPr>
+          <a:xfrm>
+            <a:off x="4867275" y="1895475"/>
+            <a:ext cx="3524250" cy="342900"/>
           </a:xfrm>
           <a:prstGeom prst="rect">
             <a:avLst/>
@@ -14831,37 +15613,64 @@
           <a:p>
             <a:pPr marL="0" indent="0" algn="l">
               <a:lnSpc>
-                <a:spcPts val="604"/>
-              </a:lnSpc>
-              <a:buNone/>
-            </a:pPr>
-            <a:r>
-              <a:rPr lang="en-US" sz="499" b="1" dirty="0">
-                <a:solidFill>
-                  <a:srgbClr val="A21942">
-                    <a:alpha val="99000"/>
-                  </a:srgbClr>
-                </a:solidFill>
-                <a:latin typeface="Inter" pitchFamily="34" charset="0"/>
-                <a:ea typeface="Inter" pitchFamily="34" charset="-122"/>
-                <a:cs typeface="Inter" pitchFamily="34" charset="-120"/>
-              </a:rPr>
-              <a:t>SDG 8</a:t>
-            </a:r>
-            <a:endParaRPr lang="en-US" sz="499" dirty="0"/>
-          </a:p>
-        </p:txBody>
-      </p:sp>
-      <p:sp>
-        <p:nvSpPr>
-          <p:cNvPr id="13" name="Text 11"/>
-          <p:cNvSpPr/>
-          <p:nvPr/>
-        </p:nvSpPr>
-        <p:spPr>
-          <a:xfrm>
-            <a:off x="5029200" y="1362075"/>
-            <a:ext cx="2381250" cy="104775"/>
+                <a:spcPts val="647"/>
+              </a:lnSpc>
+              <a:buNone/>
+            </a:pPr>
+            <a:r>
+              <a:rPr lang="en-US" sz="640" dirty="0">
+                <a:solidFill>
+                  <a:srgbClr val="66708A">
+                    <a:alpha val="99000"/>
+                  </a:srgbClr>
+                </a:solidFill>
+                <a:latin typeface="Inter" pitchFamily="34" charset="0"/>
+                <a:ea typeface="Inter" pitchFamily="34" charset="-122"/>
+                <a:cs typeface="Inter" pitchFamily="34" charset="-120"/>
+              </a:rPr>
+              <a:t>Workplace distraction and reactive communication destroy economic output at every level. KungFlow directly recovers those hours for workers and organizations.</a:t>
+            </a:r>
+            <a:endParaRPr lang="en-US" sz="640" dirty="0"/>
+          </a:p>
+        </p:txBody>
+      </p:sp>
+      <p:sp>
+        <p:nvSpPr>
+          <p:cNvPr id="30" name="Shape 28"/>
+          <p:cNvSpPr/>
+          <p:nvPr/>
+        </p:nvSpPr>
+        <p:spPr>
+          <a:xfrm>
+            <a:off x="4762500" y="2400300"/>
+            <a:ext cx="19050" cy="428625"/>
+          </a:xfrm>
+          <a:prstGeom prst="rect">
+            <a:avLst/>
+          </a:prstGeom>
+          <a:solidFill>
+            <a:srgbClr val="A21942"/>
+          </a:solidFill>
+          <a:ln/>
+        </p:spPr>
+        <p:txBody>
+          <a:bodyPr/>
+          <a:lstStyle/>
+          <a:p>
+            <a:endParaRPr lang="en-US"/>
+          </a:p>
+        </p:txBody>
+      </p:sp>
+      <p:sp>
+        <p:nvSpPr>
+          <p:cNvPr id="31" name="Text 29"/>
+          <p:cNvSpPr/>
+          <p:nvPr/>
+        </p:nvSpPr>
+        <p:spPr>
+          <a:xfrm>
+            <a:off x="4867275" y="2400299"/>
+            <a:ext cx="3524250" cy="139700"/>
           </a:xfrm>
           <a:prstGeom prst="rect">
             <a:avLst/>
@@ -14875,12 +15684,12 @@
           <a:p>
             <a:pPr marL="0" indent="0" algn="l">
               <a:lnSpc>
-                <a:spcPts val="776"/>
-              </a:lnSpc>
-              <a:buNone/>
-            </a:pPr>
-            <a:r>
-              <a:rPr lang="en-US" sz="641" b="1" dirty="0">
+                <a:spcPts val="733"/>
+              </a:lnSpc>
+              <a:buNone/>
+            </a:pPr>
+            <a:r>
+              <a:rPr lang="en-US" sz="800" b="1" dirty="0">
                 <a:solidFill>
                   <a:srgbClr val="FFFFFF">
                     <a:alpha val="99000"/>
@@ -14890,28 +15699,72 @@
                 <a:ea typeface="Inter" pitchFamily="34" charset="-122"/>
                 <a:cs typeface="Inter" pitchFamily="34" charset="-120"/>
               </a:rPr>
-              <a:t>Decent Work and Economic Growth</a:t>
-            </a:r>
-            <a:endParaRPr lang="en-US" sz="641" dirty="0"/>
-          </a:p>
-        </p:txBody>
-      </p:sp>
-      <p:sp>
-        <p:nvSpPr>
-          <p:cNvPr id="14" name="Shape 12"/>
-          <p:cNvSpPr/>
-          <p:nvPr/>
-        </p:nvSpPr>
-        <p:spPr>
-          <a:xfrm>
-            <a:off x="571500" y="1628775"/>
-            <a:ext cx="3905250" cy="2286000"/>
+              <a:t>Creates better working conditions</a:t>
+            </a:r>
+            <a:endParaRPr lang="en-US" sz="800" dirty="0"/>
+          </a:p>
+        </p:txBody>
+      </p:sp>
+      <p:sp>
+        <p:nvSpPr>
+          <p:cNvPr id="32" name="Text 30"/>
+          <p:cNvSpPr/>
+          <p:nvPr/>
+        </p:nvSpPr>
+        <p:spPr>
+          <a:xfrm>
+            <a:off x="4867275" y="2543175"/>
+            <a:ext cx="3524250" cy="342900"/>
+          </a:xfrm>
+          <a:prstGeom prst="rect">
+            <a:avLst/>
+          </a:prstGeom>
+          <a:noFill/>
+          <a:ln/>
+        </p:spPr>
+        <p:txBody>
+          <a:bodyPr wrap="square" lIns="0" tIns="0" rIns="0" bIns="0" rtlCol="0" anchor="t"/>
+          <a:lstStyle/>
+          <a:p>
+            <a:pPr marL="0" indent="0" algn="l">
+              <a:lnSpc>
+                <a:spcPts val="647"/>
+              </a:lnSpc>
+              <a:buNone/>
+            </a:pPr>
+            <a:r>
+              <a:rPr lang="en-US" sz="640" dirty="0">
+                <a:solidFill>
+                  <a:srgbClr val="66708A">
+                    <a:alpha val="99000"/>
+                  </a:srgbClr>
+                </a:solidFill>
+                <a:latin typeface="Inter" pitchFamily="34" charset="0"/>
+                <a:ea typeface="Inter" pitchFamily="34" charset="-122"/>
+                <a:cs typeface="Inter" pitchFamily="34" charset="-120"/>
+              </a:rPr>
+              <a:t>Workers protected from constant interruptions do higher-quality work, make fewer errors, and experience greater job satisfaction and autonomy.</a:t>
+            </a:r>
+            <a:endParaRPr lang="en-US" sz="640" dirty="0"/>
+          </a:p>
+        </p:txBody>
+      </p:sp>
+      <p:sp>
+        <p:nvSpPr>
+          <p:cNvPr id="33" name="Shape 31"/>
+          <p:cNvSpPr/>
+          <p:nvPr/>
+        </p:nvSpPr>
+        <p:spPr>
+          <a:xfrm>
+            <a:off x="4762500" y="3048000"/>
+            <a:ext cx="19050" cy="428625"/>
           </a:xfrm>
           <a:prstGeom prst="rect">
             <a:avLst/>
           </a:prstGeom>
           <a:solidFill>
-            <a:srgbClr val="1F2430"/>
+            <a:srgbClr val="A21942"/>
           </a:solidFill>
           <a:ln/>
         </p:spPr>
@@ -14925,14 +15778,129 @@
       </p:sp>
       <p:sp>
         <p:nvSpPr>
-          <p:cNvPr id="15" name="Shape 13"/>
-          <p:cNvSpPr/>
-          <p:nvPr/>
-        </p:nvSpPr>
-        <p:spPr>
-          <a:xfrm>
-            <a:off x="571500" y="1628775"/>
-            <a:ext cx="3905250" cy="28575"/>
+          <p:cNvPr id="34" name="Text 32"/>
+          <p:cNvSpPr/>
+          <p:nvPr/>
+        </p:nvSpPr>
+        <p:spPr>
+          <a:xfrm>
+            <a:off x="4867275" y="3047999"/>
+            <a:ext cx="3524250" cy="139700"/>
+          </a:xfrm>
+          <a:prstGeom prst="rect">
+            <a:avLst/>
+          </a:prstGeom>
+          <a:noFill/>
+          <a:ln/>
+        </p:spPr>
+        <p:txBody>
+          <a:bodyPr wrap="square" lIns="0" tIns="0" rIns="0" bIns="0" rtlCol="0" anchor="t"/>
+          <a:lstStyle/>
+          <a:p>
+            <a:pPr marL="0" indent="0" algn="l">
+              <a:lnSpc>
+                <a:spcPts val="733"/>
+              </a:lnSpc>
+              <a:buNone/>
+            </a:pPr>
+            <a:r>
+              <a:rPr lang="en-US" sz="800" b="1" dirty="0">
+                <a:solidFill>
+                  <a:srgbClr val="FFFFFF">
+                    <a:alpha val="99000"/>
+                  </a:srgbClr>
+                </a:solidFill>
+                <a:latin typeface="Inter" pitchFamily="34" charset="0"/>
+                <a:ea typeface="Inter" pitchFamily="34" charset="-122"/>
+                <a:cs typeface="Inter" pitchFamily="34" charset="-120"/>
+              </a:rPr>
+              <a:t>SDG Targets 8.2 + 8.8</a:t>
+            </a:r>
+            <a:endParaRPr lang="en-US" sz="800" dirty="0"/>
+          </a:p>
+        </p:txBody>
+      </p:sp>
+      <p:sp>
+        <p:nvSpPr>
+          <p:cNvPr id="35" name="Text 33"/>
+          <p:cNvSpPr/>
+          <p:nvPr/>
+        </p:nvSpPr>
+        <p:spPr>
+          <a:xfrm>
+            <a:off x="4867275" y="3190875"/>
+            <a:ext cx="3524250" cy="342900"/>
+          </a:xfrm>
+          <a:prstGeom prst="rect">
+            <a:avLst/>
+          </a:prstGeom>
+          <a:noFill/>
+          <a:ln/>
+        </p:spPr>
+        <p:txBody>
+          <a:bodyPr wrap="square" lIns="0" tIns="0" rIns="0" bIns="0" rtlCol="0" anchor="t"/>
+          <a:lstStyle/>
+          <a:p>
+            <a:pPr marL="0" indent="0" algn="l">
+              <a:lnSpc>
+                <a:spcPts val="647"/>
+              </a:lnSpc>
+              <a:buNone/>
+            </a:pPr>
+            <a:r>
+              <a:rPr lang="en-US" sz="640" dirty="0">
+                <a:solidFill>
+                  <a:srgbClr val="66708A">
+                    <a:alpha val="99000"/>
+                  </a:srgbClr>
+                </a:solidFill>
+                <a:latin typeface="Inter" pitchFamily="34" charset="0"/>
+                <a:ea typeface="Inter" pitchFamily="34" charset="-122"/>
+                <a:cs typeface="Inter" pitchFamily="34" charset="-120"/>
+              </a:rPr>
+              <a:t>Achieve higher productivity through innovation (8.2) and promote safe, secure working environments for all workers (8.8).</a:t>
+            </a:r>
+            <a:endParaRPr lang="en-US" sz="640" dirty="0"/>
+          </a:p>
+        </p:txBody>
+      </p:sp>
+      <p:sp>
+        <p:nvSpPr>
+          <p:cNvPr id="36" name="Shape 34"/>
+          <p:cNvSpPr/>
+          <p:nvPr/>
+        </p:nvSpPr>
+        <p:spPr>
+          <a:xfrm>
+            <a:off x="571500" y="4143375"/>
+            <a:ext cx="8001000" cy="476250"/>
+          </a:xfrm>
+          <a:prstGeom prst="rect">
+            <a:avLst/>
+          </a:prstGeom>
+          <a:solidFill>
+            <a:srgbClr val="141A26"/>
+          </a:solidFill>
+          <a:ln/>
+        </p:spPr>
+        <p:txBody>
+          <a:bodyPr/>
+          <a:lstStyle/>
+          <a:p>
+            <a:endParaRPr lang="en-US"/>
+          </a:p>
+        </p:txBody>
+      </p:sp>
+      <p:sp>
+        <p:nvSpPr>
+          <p:cNvPr id="37" name="Shape 35"/>
+          <p:cNvSpPr/>
+          <p:nvPr/>
+        </p:nvSpPr>
+        <p:spPr>
+          <a:xfrm>
+            <a:off x="571500" y="4143375"/>
+            <a:ext cx="4000500" cy="9525"/>
           </a:xfrm>
           <a:prstGeom prst="rect">
             <a:avLst/>
@@ -14952,386 +15920,14 @@
       </p:sp>
       <p:sp>
         <p:nvSpPr>
-          <p:cNvPr id="16" name="Shape 14"/>
-          <p:cNvSpPr/>
-          <p:nvPr/>
-        </p:nvSpPr>
-        <p:spPr>
-          <a:xfrm>
-            <a:off x="666750" y="1752600"/>
-            <a:ext cx="19050" cy="428625"/>
-          </a:xfrm>
-          <a:prstGeom prst="rect">
-            <a:avLst/>
-          </a:prstGeom>
-          <a:solidFill>
-            <a:srgbClr val="2A9E3B"/>
-          </a:solidFill>
-          <a:ln/>
-        </p:spPr>
-        <p:txBody>
-          <a:bodyPr/>
-          <a:lstStyle/>
-          <a:p>
-            <a:endParaRPr lang="en-US"/>
-          </a:p>
-        </p:txBody>
-      </p:sp>
-      <p:sp>
-        <p:nvSpPr>
-          <p:cNvPr id="17" name="Text 15"/>
-          <p:cNvSpPr/>
-          <p:nvPr/>
-        </p:nvSpPr>
-        <p:spPr>
-          <a:xfrm>
-            <a:off x="771525" y="1752600"/>
-            <a:ext cx="3524250" cy="100013"/>
-          </a:xfrm>
-          <a:prstGeom prst="rect">
-            <a:avLst/>
-          </a:prstGeom>
-          <a:noFill/>
-          <a:ln/>
-        </p:spPr>
-        <p:txBody>
-          <a:bodyPr wrap="square" lIns="0" tIns="0" rIns="0" bIns="0" rtlCol="0" anchor="t"/>
-          <a:lstStyle/>
-          <a:p>
-            <a:pPr marL="0" indent="0" algn="l">
-              <a:lnSpc>
-                <a:spcPts val="733"/>
-              </a:lnSpc>
-              <a:buNone/>
-            </a:pPr>
-            <a:r>
-              <a:rPr lang="en-US" sz="606" b="1" dirty="0">
-                <a:solidFill>
-                  <a:srgbClr val="FFFFFF">
-                    <a:alpha val="99000"/>
-                  </a:srgbClr>
-                </a:solidFill>
-                <a:latin typeface="Inter" pitchFamily="34" charset="0"/>
-                <a:ea typeface="Inter" pitchFamily="34" charset="-122"/>
-                <a:cs typeface="Inter" pitchFamily="34" charset="-120"/>
-              </a:rPr>
-              <a:t>Reduces workplace stress and burnout</a:t>
-            </a:r>
-            <a:endParaRPr lang="en-US" sz="606" dirty="0"/>
-          </a:p>
-        </p:txBody>
-      </p:sp>
-      <p:sp>
-        <p:nvSpPr>
-          <p:cNvPr id="18" name="Text 16"/>
-          <p:cNvSpPr/>
-          <p:nvPr/>
-        </p:nvSpPr>
-        <p:spPr>
-          <a:xfrm>
-            <a:off x="771525" y="1895475"/>
-            <a:ext cx="3524250" cy="171450"/>
-          </a:xfrm>
-          <a:prstGeom prst="rect">
-            <a:avLst/>
-          </a:prstGeom>
-          <a:noFill/>
-          <a:ln/>
-        </p:spPr>
-        <p:txBody>
-          <a:bodyPr wrap="square" lIns="0" tIns="0" rIns="0" bIns="0" rtlCol="0" anchor="t"/>
-          <a:lstStyle/>
-          <a:p>
-            <a:pPr marL="0" indent="0" algn="l">
-              <a:lnSpc>
-                <a:spcPts val="647"/>
-              </a:lnSpc>
-              <a:buNone/>
-            </a:pPr>
-            <a:r>
-              <a:rPr lang="en-US" sz="534" dirty="0">
-                <a:solidFill>
-                  <a:srgbClr val="66708A">
-                    <a:alpha val="99000"/>
-                  </a:srgbClr>
-                </a:solidFill>
-                <a:latin typeface="Inter" pitchFamily="34" charset="0"/>
-                <a:ea typeface="Inter" pitchFamily="34" charset="-122"/>
-                <a:cs typeface="Inter" pitchFamily="34" charset="-120"/>
-              </a:rPr>
-              <a:t>Chronic cognitive overload from constant notifications is directly linked to stress, anxiety disorders, and burnout. KungFlow removes that pressure automatically.</a:t>
-            </a:r>
-            <a:endParaRPr lang="en-US" sz="534" dirty="0"/>
-          </a:p>
-        </p:txBody>
-      </p:sp>
-      <p:sp>
-        <p:nvSpPr>
-          <p:cNvPr id="19" name="Shape 17"/>
-          <p:cNvSpPr/>
-          <p:nvPr/>
-        </p:nvSpPr>
-        <p:spPr>
-          <a:xfrm>
-            <a:off x="666750" y="2400300"/>
-            <a:ext cx="19050" cy="428625"/>
-          </a:xfrm>
-          <a:prstGeom prst="rect">
-            <a:avLst/>
-          </a:prstGeom>
-          <a:solidFill>
-            <a:srgbClr val="2A9E3B"/>
-          </a:solidFill>
-          <a:ln/>
-        </p:spPr>
-        <p:txBody>
-          <a:bodyPr/>
-          <a:lstStyle/>
-          <a:p>
-            <a:endParaRPr lang="en-US"/>
-          </a:p>
-        </p:txBody>
-      </p:sp>
-      <p:sp>
-        <p:nvSpPr>
-          <p:cNvPr id="20" name="Text 18"/>
-          <p:cNvSpPr/>
-          <p:nvPr/>
-        </p:nvSpPr>
-        <p:spPr>
-          <a:xfrm>
-            <a:off x="771525" y="2400300"/>
-            <a:ext cx="3524250" cy="100013"/>
-          </a:xfrm>
-          <a:prstGeom prst="rect">
-            <a:avLst/>
-          </a:prstGeom>
-          <a:noFill/>
-          <a:ln/>
-        </p:spPr>
-        <p:txBody>
-          <a:bodyPr wrap="square" lIns="0" tIns="0" rIns="0" bIns="0" rtlCol="0" anchor="t"/>
-          <a:lstStyle/>
-          <a:p>
-            <a:pPr marL="0" indent="0" algn="l">
-              <a:lnSpc>
-                <a:spcPts val="733"/>
-              </a:lnSpc>
-              <a:buNone/>
-            </a:pPr>
-            <a:r>
-              <a:rPr lang="en-US" sz="606" b="1" dirty="0">
-                <a:solidFill>
-                  <a:srgbClr val="FFFFFF">
-                    <a:alpha val="99000"/>
-                  </a:srgbClr>
-                </a:solidFill>
-                <a:latin typeface="Inter" pitchFamily="34" charset="0"/>
-                <a:ea typeface="Inter" pitchFamily="34" charset="-122"/>
-                <a:cs typeface="Inter" pitchFamily="34" charset="-120"/>
-              </a:rPr>
-              <a:t>Protects mental health at work</a:t>
-            </a:r>
-            <a:endParaRPr lang="en-US" sz="606" dirty="0"/>
-          </a:p>
-        </p:txBody>
-      </p:sp>
-      <p:sp>
-        <p:nvSpPr>
-          <p:cNvPr id="21" name="Text 19"/>
-          <p:cNvSpPr/>
-          <p:nvPr/>
-        </p:nvSpPr>
-        <p:spPr>
-          <a:xfrm>
-            <a:off x="771525" y="2543175"/>
-            <a:ext cx="3524250" cy="171450"/>
-          </a:xfrm>
-          <a:prstGeom prst="rect">
-            <a:avLst/>
-          </a:prstGeom>
-          <a:noFill/>
-          <a:ln/>
-        </p:spPr>
-        <p:txBody>
-          <a:bodyPr wrap="square" lIns="0" tIns="0" rIns="0" bIns="0" rtlCol="0" anchor="t"/>
-          <a:lstStyle/>
-          <a:p>
-            <a:pPr marL="0" indent="0" algn="l">
-              <a:lnSpc>
-                <a:spcPts val="647"/>
-              </a:lnSpc>
-              <a:buNone/>
-            </a:pPr>
-            <a:r>
-              <a:rPr lang="en-US" sz="534" dirty="0">
-                <a:solidFill>
-                  <a:srgbClr val="66708A">
-                    <a:alpha val="99000"/>
-                  </a:srgbClr>
-                </a:solidFill>
-                <a:latin typeface="Inter" pitchFamily="34" charset="0"/>
-                <a:ea typeface="Inter" pitchFamily="34" charset="-122"/>
-                <a:cs typeface="Inter" pitchFamily="34" charset="-120"/>
-              </a:rPr>
-              <a:t>By monitoring load and activating the firewall before overload sets in, KungFlow gives employees breathing room during their most cognitively demanding hours.</a:t>
-            </a:r>
-            <a:endParaRPr lang="en-US" sz="534" dirty="0"/>
-          </a:p>
-        </p:txBody>
-      </p:sp>
-      <p:sp>
-        <p:nvSpPr>
-          <p:cNvPr id="22" name="Shape 20"/>
-          <p:cNvSpPr/>
-          <p:nvPr/>
-        </p:nvSpPr>
-        <p:spPr>
-          <a:xfrm>
-            <a:off x="666750" y="3048000"/>
-            <a:ext cx="19050" cy="428625"/>
-          </a:xfrm>
-          <a:prstGeom prst="rect">
-            <a:avLst/>
-          </a:prstGeom>
-          <a:solidFill>
-            <a:srgbClr val="2A9E3B"/>
-          </a:solidFill>
-          <a:ln/>
-        </p:spPr>
-        <p:txBody>
-          <a:bodyPr/>
-          <a:lstStyle/>
-          <a:p>
-            <a:endParaRPr lang="en-US"/>
-          </a:p>
-        </p:txBody>
-      </p:sp>
-      <p:sp>
-        <p:nvSpPr>
-          <p:cNvPr id="23" name="Text 21"/>
-          <p:cNvSpPr/>
-          <p:nvPr/>
-        </p:nvSpPr>
-        <p:spPr>
-          <a:xfrm>
-            <a:off x="771525" y="3048000"/>
-            <a:ext cx="3524250" cy="100013"/>
-          </a:xfrm>
-          <a:prstGeom prst="rect">
-            <a:avLst/>
-          </a:prstGeom>
-          <a:noFill/>
-          <a:ln/>
-        </p:spPr>
-        <p:txBody>
-          <a:bodyPr wrap="square" lIns="0" tIns="0" rIns="0" bIns="0" rtlCol="0" anchor="t"/>
-          <a:lstStyle/>
-          <a:p>
-            <a:pPr marL="0" indent="0" algn="l">
-              <a:lnSpc>
-                <a:spcPts val="733"/>
-              </a:lnSpc>
-              <a:buNone/>
-            </a:pPr>
-            <a:r>
-              <a:rPr lang="en-US" sz="606" b="1" dirty="0">
-                <a:solidFill>
-                  <a:srgbClr val="FFFFFF">
-                    <a:alpha val="99000"/>
-                  </a:srgbClr>
-                </a:solidFill>
-                <a:latin typeface="Inter" pitchFamily="34" charset="0"/>
-                <a:ea typeface="Inter" pitchFamily="34" charset="-122"/>
-                <a:cs typeface="Inter" pitchFamily="34" charset="-120"/>
-              </a:rPr>
-              <a:t>SDG Target 3.4</a:t>
-            </a:r>
-            <a:endParaRPr lang="en-US" sz="606" dirty="0"/>
-          </a:p>
-        </p:txBody>
-      </p:sp>
-      <p:sp>
-        <p:nvSpPr>
-          <p:cNvPr id="24" name="Text 22"/>
-          <p:cNvSpPr/>
-          <p:nvPr/>
-        </p:nvSpPr>
-        <p:spPr>
-          <a:xfrm>
-            <a:off x="771525" y="3190875"/>
-            <a:ext cx="3524250" cy="171450"/>
-          </a:xfrm>
-          <a:prstGeom prst="rect">
-            <a:avLst/>
-          </a:prstGeom>
-          <a:noFill/>
-          <a:ln/>
-        </p:spPr>
-        <p:txBody>
-          <a:bodyPr wrap="square" lIns="0" tIns="0" rIns="0" bIns="0" rtlCol="0" anchor="t"/>
-          <a:lstStyle/>
-          <a:p>
-            <a:pPr marL="0" indent="0" algn="l">
-              <a:lnSpc>
-                <a:spcPts val="647"/>
-              </a:lnSpc>
-              <a:buNone/>
-            </a:pPr>
-            <a:r>
-              <a:rPr lang="en-US" sz="534" dirty="0">
-                <a:solidFill>
-                  <a:srgbClr val="66708A">
-                    <a:alpha val="99000"/>
-                  </a:srgbClr>
-                </a:solidFill>
-                <a:latin typeface="Inter" pitchFamily="34" charset="0"/>
-                <a:ea typeface="Inter" pitchFamily="34" charset="-122"/>
-                <a:cs typeface="Inter" pitchFamily="34" charset="-120"/>
-              </a:rPr>
-              <a:t>Promote mental health and well-being, and reduce premature mortality from non-communicable diseases including stress-related conditions.</a:t>
-            </a:r>
-            <a:endParaRPr lang="en-US" sz="534" dirty="0"/>
-          </a:p>
-        </p:txBody>
-      </p:sp>
-      <p:sp>
-        <p:nvSpPr>
-          <p:cNvPr id="25" name="Shape 23"/>
-          <p:cNvSpPr/>
-          <p:nvPr/>
-        </p:nvSpPr>
-        <p:spPr>
-          <a:xfrm>
-            <a:off x="4667250" y="1628775"/>
-            <a:ext cx="3905250" cy="2286000"/>
-          </a:xfrm>
-          <a:prstGeom prst="rect">
-            <a:avLst/>
-          </a:prstGeom>
-          <a:solidFill>
-            <a:srgbClr val="1F2430"/>
-          </a:solidFill>
-          <a:ln/>
-        </p:spPr>
-        <p:txBody>
-          <a:bodyPr/>
-          <a:lstStyle/>
-          <a:p>
-            <a:endParaRPr lang="en-US"/>
-          </a:p>
-        </p:txBody>
-      </p:sp>
-      <p:sp>
-        <p:nvSpPr>
-          <p:cNvPr id="26" name="Shape 24"/>
-          <p:cNvSpPr/>
-          <p:nvPr/>
-        </p:nvSpPr>
-        <p:spPr>
-          <a:xfrm>
-            <a:off x="4667250" y="1628775"/>
-            <a:ext cx="3905250" cy="28575"/>
+          <p:cNvPr id="38" name="Shape 36"/>
+          <p:cNvSpPr/>
+          <p:nvPr/>
+        </p:nvSpPr>
+        <p:spPr>
+          <a:xfrm>
+            <a:off x="4572000" y="4143375"/>
+            <a:ext cx="4000500" cy="9525"/>
           </a:xfrm>
           <a:prstGeom prst="rect">
             <a:avLst/>
@@ -15351,432 +15947,6 @@
       </p:sp>
       <p:sp>
         <p:nvSpPr>
-          <p:cNvPr id="27" name="Shape 25"/>
-          <p:cNvSpPr/>
-          <p:nvPr/>
-        </p:nvSpPr>
-        <p:spPr>
-          <a:xfrm>
-            <a:off x="4762500" y="1752600"/>
-            <a:ext cx="19050" cy="428625"/>
-          </a:xfrm>
-          <a:prstGeom prst="rect">
-            <a:avLst/>
-          </a:prstGeom>
-          <a:solidFill>
-            <a:srgbClr val="A21942"/>
-          </a:solidFill>
-          <a:ln/>
-        </p:spPr>
-        <p:txBody>
-          <a:bodyPr/>
-          <a:lstStyle/>
-          <a:p>
-            <a:endParaRPr lang="en-US"/>
-          </a:p>
-        </p:txBody>
-      </p:sp>
-      <p:sp>
-        <p:nvSpPr>
-          <p:cNvPr id="28" name="Text 26"/>
-          <p:cNvSpPr/>
-          <p:nvPr/>
-        </p:nvSpPr>
-        <p:spPr>
-          <a:xfrm>
-            <a:off x="4867275" y="1752600"/>
-            <a:ext cx="3524250" cy="100013"/>
-          </a:xfrm>
-          <a:prstGeom prst="rect">
-            <a:avLst/>
-          </a:prstGeom>
-          <a:noFill/>
-          <a:ln/>
-        </p:spPr>
-        <p:txBody>
-          <a:bodyPr wrap="square" lIns="0" tIns="0" rIns="0" bIns="0" rtlCol="0" anchor="t"/>
-          <a:lstStyle/>
-          <a:p>
-            <a:pPr marL="0" indent="0" algn="l">
-              <a:lnSpc>
-                <a:spcPts val="733"/>
-              </a:lnSpc>
-              <a:buNone/>
-            </a:pPr>
-            <a:r>
-              <a:rPr lang="en-US" sz="606" b="1" dirty="0">
-                <a:solidFill>
-                  <a:srgbClr val="FFFFFF">
-                    <a:alpha val="99000"/>
-                  </a:srgbClr>
-                </a:solidFill>
-                <a:latin typeface="Inter" pitchFamily="34" charset="0"/>
-                <a:ea typeface="Inter" pitchFamily="34" charset="-122"/>
-                <a:cs typeface="Inter" pitchFamily="34" charset="-120"/>
-              </a:rPr>
-              <a:t>$650B in productivity lost annually</a:t>
-            </a:r>
-            <a:endParaRPr lang="en-US" sz="606" dirty="0"/>
-          </a:p>
-        </p:txBody>
-      </p:sp>
-      <p:sp>
-        <p:nvSpPr>
-          <p:cNvPr id="29" name="Text 27"/>
-          <p:cNvSpPr/>
-          <p:nvPr/>
-        </p:nvSpPr>
-        <p:spPr>
-          <a:xfrm>
-            <a:off x="4867275" y="1895475"/>
-            <a:ext cx="3524250" cy="171450"/>
-          </a:xfrm>
-          <a:prstGeom prst="rect">
-            <a:avLst/>
-          </a:prstGeom>
-          <a:noFill/>
-          <a:ln/>
-        </p:spPr>
-        <p:txBody>
-          <a:bodyPr wrap="square" lIns="0" tIns="0" rIns="0" bIns="0" rtlCol="0" anchor="t"/>
-          <a:lstStyle/>
-          <a:p>
-            <a:pPr marL="0" indent="0" algn="l">
-              <a:lnSpc>
-                <a:spcPts val="647"/>
-              </a:lnSpc>
-              <a:buNone/>
-            </a:pPr>
-            <a:r>
-              <a:rPr lang="en-US" sz="534" dirty="0">
-                <a:solidFill>
-                  <a:srgbClr val="66708A">
-                    <a:alpha val="99000"/>
-                  </a:srgbClr>
-                </a:solidFill>
-                <a:latin typeface="Inter" pitchFamily="34" charset="0"/>
-                <a:ea typeface="Inter" pitchFamily="34" charset="-122"/>
-                <a:cs typeface="Inter" pitchFamily="34" charset="-120"/>
-              </a:rPr>
-              <a:t>Workplace distraction and reactive communication destroy economic output at every level. KungFlow directly recovers those hours for workers and organizations.</a:t>
-            </a:r>
-            <a:endParaRPr lang="en-US" sz="534" dirty="0"/>
-          </a:p>
-        </p:txBody>
-      </p:sp>
-      <p:sp>
-        <p:nvSpPr>
-          <p:cNvPr id="30" name="Shape 28"/>
-          <p:cNvSpPr/>
-          <p:nvPr/>
-        </p:nvSpPr>
-        <p:spPr>
-          <a:xfrm>
-            <a:off x="4762500" y="2400300"/>
-            <a:ext cx="19050" cy="428625"/>
-          </a:xfrm>
-          <a:prstGeom prst="rect">
-            <a:avLst/>
-          </a:prstGeom>
-          <a:solidFill>
-            <a:srgbClr val="A21942"/>
-          </a:solidFill>
-          <a:ln/>
-        </p:spPr>
-        <p:txBody>
-          <a:bodyPr/>
-          <a:lstStyle/>
-          <a:p>
-            <a:endParaRPr lang="en-US"/>
-          </a:p>
-        </p:txBody>
-      </p:sp>
-      <p:sp>
-        <p:nvSpPr>
-          <p:cNvPr id="31" name="Text 29"/>
-          <p:cNvSpPr/>
-          <p:nvPr/>
-        </p:nvSpPr>
-        <p:spPr>
-          <a:xfrm>
-            <a:off x="4867275" y="2400300"/>
-            <a:ext cx="3524250" cy="100013"/>
-          </a:xfrm>
-          <a:prstGeom prst="rect">
-            <a:avLst/>
-          </a:prstGeom>
-          <a:noFill/>
-          <a:ln/>
-        </p:spPr>
-        <p:txBody>
-          <a:bodyPr wrap="square" lIns="0" tIns="0" rIns="0" bIns="0" rtlCol="0" anchor="t"/>
-          <a:lstStyle/>
-          <a:p>
-            <a:pPr marL="0" indent="0" algn="l">
-              <a:lnSpc>
-                <a:spcPts val="733"/>
-              </a:lnSpc>
-              <a:buNone/>
-            </a:pPr>
-            <a:r>
-              <a:rPr lang="en-US" sz="606" b="1" dirty="0">
-                <a:solidFill>
-                  <a:srgbClr val="FFFFFF">
-                    <a:alpha val="99000"/>
-                  </a:srgbClr>
-                </a:solidFill>
-                <a:latin typeface="Inter" pitchFamily="34" charset="0"/>
-                <a:ea typeface="Inter" pitchFamily="34" charset="-122"/>
-                <a:cs typeface="Inter" pitchFamily="34" charset="-120"/>
-              </a:rPr>
-              <a:t>Creates better working conditions</a:t>
-            </a:r>
-            <a:endParaRPr lang="en-US" sz="606" dirty="0"/>
-          </a:p>
-        </p:txBody>
-      </p:sp>
-      <p:sp>
-        <p:nvSpPr>
-          <p:cNvPr id="32" name="Text 30"/>
-          <p:cNvSpPr/>
-          <p:nvPr/>
-        </p:nvSpPr>
-        <p:spPr>
-          <a:xfrm>
-            <a:off x="4867275" y="2543175"/>
-            <a:ext cx="3524250" cy="171450"/>
-          </a:xfrm>
-          <a:prstGeom prst="rect">
-            <a:avLst/>
-          </a:prstGeom>
-          <a:noFill/>
-          <a:ln/>
-        </p:spPr>
-        <p:txBody>
-          <a:bodyPr wrap="square" lIns="0" tIns="0" rIns="0" bIns="0" rtlCol="0" anchor="t"/>
-          <a:lstStyle/>
-          <a:p>
-            <a:pPr marL="0" indent="0" algn="l">
-              <a:lnSpc>
-                <a:spcPts val="647"/>
-              </a:lnSpc>
-              <a:buNone/>
-            </a:pPr>
-            <a:r>
-              <a:rPr lang="en-US" sz="534" dirty="0">
-                <a:solidFill>
-                  <a:srgbClr val="66708A">
-                    <a:alpha val="99000"/>
-                  </a:srgbClr>
-                </a:solidFill>
-                <a:latin typeface="Inter" pitchFamily="34" charset="0"/>
-                <a:ea typeface="Inter" pitchFamily="34" charset="-122"/>
-                <a:cs typeface="Inter" pitchFamily="34" charset="-120"/>
-              </a:rPr>
-              <a:t>Workers protected from constant interruptions do higher-quality work, make fewer errors, and experience greater job satisfaction and autonomy.</a:t>
-            </a:r>
-            <a:endParaRPr lang="en-US" sz="534" dirty="0"/>
-          </a:p>
-        </p:txBody>
-      </p:sp>
-      <p:sp>
-        <p:nvSpPr>
-          <p:cNvPr id="33" name="Shape 31"/>
-          <p:cNvSpPr/>
-          <p:nvPr/>
-        </p:nvSpPr>
-        <p:spPr>
-          <a:xfrm>
-            <a:off x="4762500" y="3048000"/>
-            <a:ext cx="19050" cy="428625"/>
-          </a:xfrm>
-          <a:prstGeom prst="rect">
-            <a:avLst/>
-          </a:prstGeom>
-          <a:solidFill>
-            <a:srgbClr val="A21942"/>
-          </a:solidFill>
-          <a:ln/>
-        </p:spPr>
-        <p:txBody>
-          <a:bodyPr/>
-          <a:lstStyle/>
-          <a:p>
-            <a:endParaRPr lang="en-US"/>
-          </a:p>
-        </p:txBody>
-      </p:sp>
-      <p:sp>
-        <p:nvSpPr>
-          <p:cNvPr id="34" name="Text 32"/>
-          <p:cNvSpPr/>
-          <p:nvPr/>
-        </p:nvSpPr>
-        <p:spPr>
-          <a:xfrm>
-            <a:off x="4867275" y="3048000"/>
-            <a:ext cx="3524250" cy="100013"/>
-          </a:xfrm>
-          <a:prstGeom prst="rect">
-            <a:avLst/>
-          </a:prstGeom>
-          <a:noFill/>
-          <a:ln/>
-        </p:spPr>
-        <p:txBody>
-          <a:bodyPr wrap="square" lIns="0" tIns="0" rIns="0" bIns="0" rtlCol="0" anchor="t"/>
-          <a:lstStyle/>
-          <a:p>
-            <a:pPr marL="0" indent="0" algn="l">
-              <a:lnSpc>
-                <a:spcPts val="733"/>
-              </a:lnSpc>
-              <a:buNone/>
-            </a:pPr>
-            <a:r>
-              <a:rPr lang="en-US" sz="606" b="1" dirty="0">
-                <a:solidFill>
-                  <a:srgbClr val="FFFFFF">
-                    <a:alpha val="99000"/>
-                  </a:srgbClr>
-                </a:solidFill>
-                <a:latin typeface="Inter" pitchFamily="34" charset="0"/>
-                <a:ea typeface="Inter" pitchFamily="34" charset="-122"/>
-                <a:cs typeface="Inter" pitchFamily="34" charset="-120"/>
-              </a:rPr>
-              <a:t>SDG Targets 8.2 + 8.8</a:t>
-            </a:r>
-            <a:endParaRPr lang="en-US" sz="606" dirty="0"/>
-          </a:p>
-        </p:txBody>
-      </p:sp>
-      <p:sp>
-        <p:nvSpPr>
-          <p:cNvPr id="35" name="Text 33"/>
-          <p:cNvSpPr/>
-          <p:nvPr/>
-        </p:nvSpPr>
-        <p:spPr>
-          <a:xfrm>
-            <a:off x="4867275" y="3190875"/>
-            <a:ext cx="3524250" cy="171450"/>
-          </a:xfrm>
-          <a:prstGeom prst="rect">
-            <a:avLst/>
-          </a:prstGeom>
-          <a:noFill/>
-          <a:ln/>
-        </p:spPr>
-        <p:txBody>
-          <a:bodyPr wrap="square" lIns="0" tIns="0" rIns="0" bIns="0" rtlCol="0" anchor="t"/>
-          <a:lstStyle/>
-          <a:p>
-            <a:pPr marL="0" indent="0" algn="l">
-              <a:lnSpc>
-                <a:spcPts val="647"/>
-              </a:lnSpc>
-              <a:buNone/>
-            </a:pPr>
-            <a:r>
-              <a:rPr lang="en-US" sz="534" dirty="0">
-                <a:solidFill>
-                  <a:srgbClr val="66708A">
-                    <a:alpha val="99000"/>
-                  </a:srgbClr>
-                </a:solidFill>
-                <a:latin typeface="Inter" pitchFamily="34" charset="0"/>
-                <a:ea typeface="Inter" pitchFamily="34" charset="-122"/>
-                <a:cs typeface="Inter" pitchFamily="34" charset="-120"/>
-              </a:rPr>
-              <a:t>Achieve higher productivity through innovation (8.2) and promote safe, secure working environments for all workers (8.8).</a:t>
-            </a:r>
-            <a:endParaRPr lang="en-US" sz="534" dirty="0"/>
-          </a:p>
-        </p:txBody>
-      </p:sp>
-      <p:sp>
-        <p:nvSpPr>
-          <p:cNvPr id="36" name="Shape 34"/>
-          <p:cNvSpPr/>
-          <p:nvPr/>
-        </p:nvSpPr>
-        <p:spPr>
-          <a:xfrm>
-            <a:off x="571500" y="4143375"/>
-            <a:ext cx="8001000" cy="476250"/>
-          </a:xfrm>
-          <a:prstGeom prst="rect">
-            <a:avLst/>
-          </a:prstGeom>
-          <a:solidFill>
-            <a:srgbClr val="141A26"/>
-          </a:solidFill>
-          <a:ln/>
-        </p:spPr>
-        <p:txBody>
-          <a:bodyPr/>
-          <a:lstStyle/>
-          <a:p>
-            <a:endParaRPr lang="en-US"/>
-          </a:p>
-        </p:txBody>
-      </p:sp>
-      <p:sp>
-        <p:nvSpPr>
-          <p:cNvPr id="37" name="Shape 35"/>
-          <p:cNvSpPr/>
-          <p:nvPr/>
-        </p:nvSpPr>
-        <p:spPr>
-          <a:xfrm>
-            <a:off x="571500" y="4143375"/>
-            <a:ext cx="4000500" cy="9525"/>
-          </a:xfrm>
-          <a:prstGeom prst="rect">
-            <a:avLst/>
-          </a:prstGeom>
-          <a:solidFill>
-            <a:srgbClr val="2A9E3B"/>
-          </a:solidFill>
-          <a:ln/>
-        </p:spPr>
-        <p:txBody>
-          <a:bodyPr/>
-          <a:lstStyle/>
-          <a:p>
-            <a:endParaRPr lang="en-US"/>
-          </a:p>
-        </p:txBody>
-      </p:sp>
-      <p:sp>
-        <p:nvSpPr>
-          <p:cNvPr id="38" name="Shape 36"/>
-          <p:cNvSpPr/>
-          <p:nvPr/>
-        </p:nvSpPr>
-        <p:spPr>
-          <a:xfrm>
-            <a:off x="4572000" y="4143375"/>
-            <a:ext cx="4000500" cy="9525"/>
-          </a:xfrm>
-          <a:prstGeom prst="rect">
-            <a:avLst/>
-          </a:prstGeom>
-          <a:solidFill>
-            <a:srgbClr val="A21942"/>
-          </a:solidFill>
-          <a:ln/>
-        </p:spPr>
-        <p:txBody>
-          <a:bodyPr/>
-          <a:lstStyle/>
-          <a:p>
-            <a:endParaRPr lang="en-US"/>
-          </a:p>
-        </p:txBody>
-      </p:sp>
-      <p:sp>
-        <p:nvSpPr>
           <p:cNvPr id="39" name="Text 37"/>
           <p:cNvSpPr/>
           <p:nvPr/>
@@ -15784,7 +15954,7 @@
         <p:spPr>
           <a:xfrm>
             <a:off x="571500" y="4295775"/>
-            <a:ext cx="8001000" cy="114300"/>
+            <a:ext cx="8001000" cy="165100"/>
           </a:xfrm>
           <a:prstGeom prst="rect">
             <a:avLst/>
@@ -15803,7 +15973,7 @@
               <a:buNone/>
             </a:pPr>
             <a:r>
-              <a:rPr lang="en-US" sz="713" b="1" dirty="0">
+              <a:rPr lang="en-US" sz="850" b="1" dirty="0">
                 <a:solidFill>
                   <a:srgbClr val="D6DEF0">
                     <a:alpha val="99000"/>
@@ -15815,7 +15985,7 @@
               </a:rPr>
               <a:t>KungFlow is not just a productivity tool -- it is infrastructure for healthier, more humane workplaces.</a:t>
             </a:r>
-            <a:endParaRPr lang="en-US" sz="713" dirty="0"/>
+            <a:endParaRPr lang="en-US" sz="850" dirty="0"/>
           </a:p>
         </p:txBody>
       </p:sp>
@@ -15843,6 +16013,66 @@
           <a:xfrm>
             <a:off x="8648700" y="190500"/>
             <a:ext cx="292100" cy="292100"/>
+          </a:xfrm>
+          <a:prstGeom prst="rect">
+            <a:avLst/>
+          </a:prstGeom>
+        </p:spPr>
+      </p:pic>
+      <p:pic>
+        <p:nvPicPr>
+          <p:cNvPr id="42" name="Official SDG 3">
+            <a:extLst>
+              <a:ext uri="{FF2B5EF4-FFF2-40B4-BE49-F238E27FC236}">
+                <a16:creationId xmlns:a16="http://schemas.microsoft.com/office/drawing/2014/main" id="{20851400-9F4A-DCDF-A787-0D4014543EAE}"/>
+              </a:ext>
+            </a:extLst>
+          </p:cNvPr>
+          <p:cNvPicPr>
+            <a:picLocks/>
+          </p:cNvPicPr>
+          <p:nvPr/>
+        </p:nvPicPr>
+        <p:blipFill>
+          <a:blip r:embed="rId4"/>
+          <a:stretch>
+            <a:fillRect/>
+          </a:stretch>
+        </p:blipFill>
+        <p:spPr>
+          <a:xfrm>
+            <a:off x="571500" y="1104900"/>
+            <a:ext cx="482600" cy="482600"/>
+          </a:xfrm>
+          <a:prstGeom prst="rect">
+            <a:avLst/>
+          </a:prstGeom>
+        </p:spPr>
+      </p:pic>
+      <p:pic>
+        <p:nvPicPr>
+          <p:cNvPr id="44" name="Official SDG 8">
+            <a:extLst>
+              <a:ext uri="{FF2B5EF4-FFF2-40B4-BE49-F238E27FC236}">
+                <a16:creationId xmlns:a16="http://schemas.microsoft.com/office/drawing/2014/main" id="{B7EE321C-2070-887C-47E3-ECF929CD6BD6}"/>
+              </a:ext>
+            </a:extLst>
+          </p:cNvPr>
+          <p:cNvPicPr>
+            <a:picLocks/>
+          </p:cNvPicPr>
+          <p:nvPr/>
+        </p:nvPicPr>
+        <p:blipFill>
+          <a:blip r:embed="rId5"/>
+          <a:stretch>
+            <a:fillRect/>
+          </a:stretch>
+        </p:blipFill>
+        <p:spPr>
+          <a:xfrm>
+            <a:off x="4667250" y="1104900"/>
+            <a:ext cx="482600" cy="482600"/>
           </a:xfrm>
           <a:prstGeom prst="rect">
             <a:avLst/>

</xml_diff>